<commit_message>
docs: fill submission texts and deck with verified chain, live-order, test and replay facts
Co-Authored-By: Claude Opus 5.5 <noreply@anthropic.com>
</commit_message>
<xml_diff>
--- a/docs/pitch/GRAIL-pitch.pptx
+++ b/docs/pitch/GRAIL-pitch.pptx
@@ -1407,7 +1407,7 @@
           <a:p>
             <a:r>
               <a:rPr lang="en-US" dirty="0"/>
-              <a:t>Open with the live number from the dashboard, not with the team. "You bought five coins. Because they rise and fall together, you really hold &lt;TBD&gt; independent bets. And if an AI agent traded them for you, you could not check its record either. GRAIL fixes both."</a:t>
+              <a:t>Open with the live number from the dashboard, not with the team. "You bought five coins. Because they rise and fall together, over the last 30 days they behaved like 1.36 independent bets. And if an AI agent traded them for you, you could not check its record either. GRAIL fixes both."</a:t>
             </a:r>
             <a:endParaRPr lang="en-US" dirty="0"/>
           </a:p>
@@ -1495,7 +1495,7 @@
           <a:p>
             <a:r>
               <a:rPr lang="en-US" dirty="0"/>
-              <a:t>Quality in one sentence: the decision is built the same way in Python, in the Avalanche contract and in your browser, and they all agree. Mention the next step only briefly. Then close with: 'Backtests can lie. Avalanche can't.' and stop talking.</a:t>
+              <a:t>Quality in one sentence: the decision is built the same way in Python, in the Avalanche contract and in your browser, and they all agree. On risk: in a 30-day replay its worst drop was 7.5% versus 14.5% for buy-and-hold; it earned less (+1.8% vs +8.8%), and we say so. Mention the next step only briefly. Then close with: 'Backtests can lie. Avalanche can't.' and stop talking.</a:t>
             </a:r>
             <a:endParaRPr lang="en-US" dirty="0"/>
           </a:p>
@@ -2736,7 +2736,7 @@
                 <a:ea typeface="Calibri" pitchFamily="34" charset="-122"/>
                 <a:cs typeface="Calibri" pitchFamily="34" charset="-120"/>
               </a:rPr>
-              <a:t>Because they move together, they count as &lt;TBD&gt; independent bets.</a:t>
+              <a:t>Because they move together, they counted as 1.36 independent bets on average over the last 30 days.</a:t>
             </a:r>
             <a:endParaRPr lang="en-US" sz="1500" dirty="0"/>
           </a:p>
@@ -3247,7 +3247,7 @@
                 <a:ea typeface="Cambria" pitchFamily="34" charset="-122"/>
                 <a:cs typeface="Cambria" pitchFamily="34" charset="-120"/>
               </a:rPr>
-              <a:t>&lt;TBD&gt;</a:t>
+              <a:t>1.36</a:t>
             </a:r>
             <a:endParaRPr lang="en-US" sz="2600" dirty="0"/>
           </a:p>
@@ -3261,8 +3261,8 @@
         </p:nvSpPr>
         <p:spPr>
           <a:xfrm>
-            <a:off x="6995160" y="3291840"/>
-            <a:ext cx="2011680" cy="274320"/>
+            <a:off x="6949440" y="3291840"/>
+            <a:ext cx="2103120" cy="274320"/>
           </a:xfrm>
           <a:prstGeom prst="rect">
             <a:avLst/>
@@ -3278,7 +3278,7 @@
               <a:buNone/>
             </a:pPr>
             <a:r>
-              <a:rPr lang="en-US" sz="1200" dirty="0">
+              <a:rPr lang="en-US" sz="1100" dirty="0">
                 <a:solidFill>
                   <a:srgbClr val="E8B04B"/>
                 </a:solidFill>
@@ -3286,9 +3286,9 @@
                 <a:ea typeface="Calibri" pitchFamily="34" charset="-122"/>
                 <a:cs typeface="Calibri" pitchFamily="34" charset="-120"/>
               </a:rPr>
-              <a:t>independent bets</a:t>
-            </a:r>
-            <a:endParaRPr lang="en-US" sz="1200" dirty="0"/>
+              <a:t>independent bets · 30-day avg</a:t>
+            </a:r>
+            <a:endParaRPr lang="en-US" sz="1100" dirty="0"/>
           </a:p>
         </p:txBody>
       </p:sp>
@@ -3462,7 +3462,7 @@
                 <a:ea typeface="Cambria" pitchFamily="34" charset="-122"/>
                 <a:cs typeface="Cambria" pitchFamily="34" charset="-120"/>
               </a:rPr>
-              <a:t>84</a:t>
+              <a:t>104</a:t>
             </a:r>
             <a:endParaRPr lang="en-US" sz="3000" dirty="0"/>
           </a:p>
@@ -3567,7 +3567,7 @@
                 <a:ea typeface="Cambria" pitchFamily="34" charset="-122"/>
                 <a:cs typeface="Cambria" pitchFamily="34" charset="-120"/>
               </a:rPr>
-              <a:t>78</a:t>
+              <a:t>157</a:t>
             </a:r>
             <a:endParaRPr lang="en-US" sz="3000" dirty="0"/>
           </a:p>
@@ -3606,7 +3606,7 @@
                 <a:ea typeface="Calibri" pitchFamily="34" charset="-122"/>
                 <a:cs typeface="Calibri" pitchFamily="34" charset="-120"/>
               </a:rPr>
-              <a:t>OKX trading-layer tests</a:t>
+              <a:t>OKX trading and loop tests</a:t>
             </a:r>
             <a:endParaRPr lang="en-US" sz="1100" dirty="0"/>
           </a:p>
@@ -3672,7 +3672,7 @@
                 <a:ea typeface="Cambria" pitchFamily="34" charset="-122"/>
                 <a:cs typeface="Cambria" pitchFamily="34" charset="-120"/>
               </a:rPr>
-              <a:t>25</a:t>
+              <a:t>38</a:t>
             </a:r>
             <a:endParaRPr lang="en-US" sz="3000" dirty="0"/>
           </a:p>
@@ -3725,17 +3725,17 @@
         </p:nvSpPr>
         <p:spPr>
           <a:xfrm>
-            <a:off x="457200" y="3337560"/>
-            <a:ext cx="8229600" cy="274320"/>
-          </a:xfrm>
-          <a:prstGeom prst="rect">
-            <a:avLst/>
-          </a:prstGeom>
-          <a:noFill/>
-          <a:ln/>
-        </p:spPr>
-        <p:txBody>
-          <a:bodyPr wrap="square" lIns="0" tIns="0" rIns="0" bIns="0" rtlCol="0" anchor="ctr"/>
+            <a:off x="457200" y="3364992"/>
+            <a:ext cx="8229600" cy="384048"/>
+          </a:xfrm>
+          <a:prstGeom prst="rect">
+            <a:avLst/>
+          </a:prstGeom>
+          <a:noFill/>
+          <a:ln/>
+        </p:spPr>
+        <p:txBody>
+          <a:bodyPr wrap="square" lIns="0" tIns="0" rIns="0" bIns="0" rtlCol="0" anchor="t"/>
           <a:lstStyle/>
           <a:p>
             <a:pPr indent="0" marL="0">
@@ -3744,13 +3744,13 @@
             <a:r>
               <a:rPr lang="en-US" sz="1000" i="1" dirty="0">
                 <a:solidFill>
-                  <a:srgbClr val="5B6578"/>
-                </a:solidFill>
-                <a:latin typeface="Calibri" pitchFamily="34" charset="0"/>
-                <a:ea typeface="Calibri" pitchFamily="34" charset="-122"/>
-                <a:cs typeface="Calibri" pitchFamily="34" charset="-120"/>
-              </a:rPr>
-              <a:t>Automated tests passing, 17 Oct, 14:43.</a:t>
+                  <a:srgbClr val="8A94A8"/>
+                </a:solidFill>
+                <a:latin typeface="Calibri" pitchFamily="34" charset="0"/>
+                <a:ea typeface="Calibri" pitchFamily="34" charset="-122"/>
+                <a:cs typeface="Calibri" pitchFamily="34" charset="-120"/>
+              </a:rPr>
+              <a:t>Automated tests passing, 17 Oct. 30-day replay on real OKX prices: worst drop 7.5% vs 14.5% for buy-and-hold (return +1.8% vs +8.8%; no claim that it beats buy-and-hold).</a:t>
             </a:r>
             <a:endParaRPr lang="en-US" sz="1000" dirty="0"/>
           </a:p>
@@ -3764,7 +3764,7 @@
         </p:nvSpPr>
         <p:spPr>
           <a:xfrm>
-            <a:off x="457200" y="3703320"/>
+            <a:off x="457200" y="3886200"/>
             <a:ext cx="8229600" cy="548640"/>
           </a:xfrm>
           <a:prstGeom prst="rect">
@@ -3817,7 +3817,7 @@
         </p:nvSpPr>
         <p:spPr>
           <a:xfrm>
-            <a:off x="457200" y="4434840"/>
+            <a:off x="457200" y="4526280"/>
             <a:ext cx="8229600" cy="274320"/>
           </a:xfrm>
           <a:prstGeom prst="rect">
@@ -4738,7 +4738,7 @@
                 <a:ea typeface="Calibri" pitchFamily="34" charset="-122"/>
                 <a:cs typeface="Calibri" pitchFamily="34" charset="-120"/>
               </a:rPr>
-              <a:t>≈ &lt;TBD&gt; bets</a:t>
+              <a:t>≈ 1.36 bets</a:t>
             </a:r>
             <a:endParaRPr lang="en-US" sz="1400" dirty="0"/>
           </a:p>
@@ -4983,7 +4983,7 @@
                 <a:ea typeface="Calibri" pitchFamily="34" charset="-122"/>
                 <a:cs typeface="Calibri" pitchFamily="34" charset="-120"/>
               </a:rPr>
-              <a:t>Live today</a:t>
+              <a:t>Last 30 days</a:t>
             </a:r>
             <a:endParaRPr lang="en-US" sz="1100" dirty="0"/>
           </a:p>
@@ -5022,7 +5022,7 @@
                 <a:ea typeface="Cambria" pitchFamily="34" charset="-122"/>
                 <a:cs typeface="Cambria" pitchFamily="34" charset="-120"/>
               </a:rPr>
-              <a:t>&lt;TBD&gt;</a:t>
+              <a:t>1.36</a:t>
             </a:r>
             <a:endParaRPr lang="en-US" sz="3000" dirty="0"/>
           </a:p>
@@ -5061,7 +5061,7 @@
                 <a:ea typeface="Calibri" pitchFamily="34" charset="-122"/>
                 <a:cs typeface="Calibri" pitchFamily="34" charset="-120"/>
               </a:rPr>
-              <a:t>independent bets from 5 coins (togetherness &lt;TBD&gt;)</a:t>
+              <a:t>independent bets from 5 coins, on average (replay on real OKX prices)</a:t>
             </a:r>
             <a:endParaRPr lang="en-US" sz="1100" dirty="0"/>
           </a:p>
@@ -6266,7 +6266,7 @@
                 <a:ea typeface="Cambria" pitchFamily="34" charset="-122"/>
                 <a:cs typeface="Cambria" pitchFamily="34" charset="-120"/>
               </a:rPr>
-              <a:t>&lt;TBD&gt;</a:t>
+              <a:t>2</a:t>
             </a:r>
             <a:endParaRPr lang="en-US" sz="2800" dirty="0"/>
           </a:p>
@@ -6305,7 +6305,7 @@
                 <a:ea typeface="Calibri" pitchFamily="34" charset="-122"/>
                 <a:cs typeface="Calibri" pitchFamily="34" charset="-120"/>
               </a:rPr>
-              <a:t>cycles run today, each one sealed</a:t>
+              <a:t>cycles sealed on Avalanche so far</a:t>
             </a:r>
             <a:endParaRPr lang="en-US" sz="1300" dirty="0"/>
           </a:p>
@@ -8131,7 +8131,7 @@
                 <a:ea typeface="Calibri" pitchFamily="34" charset="-122"/>
                 <a:cs typeface="Calibri" pitchFamily="34" charset="-120"/>
               </a:rPr>
-              <a:t>Decisions are still sealed, orders are only simulated. Going live is a human decision.</a:t>
+              <a:t>Going live is a human decision: the first live order (BUY 2 USDT of BTC, 17 Oct, 15:37) needed an explicit switch.</a:t>
             </a:r>
             <a:endParaRPr lang="en-US" sz="1300" dirty="0"/>
           </a:p>
@@ -9961,8 +9961,8 @@
         </p:nvSpPr>
         <p:spPr>
           <a:xfrm>
-            <a:off x="457200" y="4389120"/>
-            <a:ext cx="8229600" cy="274320"/>
+            <a:off x="457200" y="4343400"/>
+            <a:ext cx="8229600" cy="256032"/>
           </a:xfrm>
           <a:prstGeom prst="rect">
             <a:avLst/>
@@ -9987,6 +9987,45 @@
                 <a:cs typeface="Courier New" pitchFamily="34" charset="-120"/>
               </a:rPr>
               <a:t>Record contract (Fuji): 0x1B5fcf6DeFf2F9375338A2C35932224522118851</a:t>
+            </a:r>
+            <a:endParaRPr lang="en-US" sz="1000" dirty="0"/>
+          </a:p>
+        </p:txBody>
+      </p:sp>
+      <p:sp>
+        <p:nvSpPr>
+          <p:cNvPr id="28" name="Text 26"/>
+          <p:cNvSpPr/>
+          <p:nvPr/>
+        </p:nvSpPr>
+        <p:spPr>
+          <a:xfrm>
+            <a:off x="457200" y="4617720"/>
+            <a:ext cx="8229600" cy="256032"/>
+          </a:xfrm>
+          <a:prstGeom prst="rect">
+            <a:avLst/>
+          </a:prstGeom>
+          <a:noFill/>
+          <a:ln/>
+        </p:spPr>
+        <p:txBody>
+          <a:bodyPr wrap="square" lIns="0" tIns="0" rIns="0" bIns="0" rtlCol="0" anchor="ctr"/>
+          <a:lstStyle/>
+          <a:p>
+            <a:pPr indent="0" marL="0">
+              <a:buNone/>
+            </a:pPr>
+            <a:r>
+              <a:rPr lang="en-US" sz="1000" dirty="0">
+                <a:solidFill>
+                  <a:srgbClr val="8A94A8"/>
+                </a:solidFill>
+                <a:latin typeface="Courier New" pitchFamily="34" charset="0"/>
+                <a:ea typeface="Courier New" pitchFamily="34" charset="-122"/>
+                <a:cs typeface="Courier New" pitchFamily="34" charset="-120"/>
+              </a:rPr>
+              <a:t>First live order: BUY 2 USDT of BTC · OKX 4017748393474314240 · sealed 0x16f2…9569 → opened 0xae65…41f7</a:t>
             </a:r>
             <a:endParaRPr lang="en-US" sz="1000" dirty="0"/>
           </a:p>
@@ -11035,7 +11074,74 @@
         </p:nvSpPr>
         <p:spPr>
           <a:xfrm>
-            <a:off x="457200" y="4297680"/>
+            <a:off x="457200" y="4224528"/>
+            <a:ext cx="8229600" cy="274320"/>
+          </a:xfrm>
+          <a:prstGeom prst="rect">
+            <a:avLst/>
+          </a:prstGeom>
+          <a:noFill/>
+          <a:ln/>
+        </p:spPr>
+        <p:txBody>
+          <a:bodyPr wrap="square" lIns="0" tIns="0" rIns="0" bIns="0" rtlCol="0" anchor="ctr"/>
+          <a:lstStyle/>
+          <a:p>
+            <a:pPr indent="0" marL="0">
+              <a:buNone/>
+            </a:pPr>
+            <a:r>
+              <a:rPr lang="en-US" sz="1200" dirty="0">
+                <a:solidFill>
+                  <a:srgbClr val="8A94A8"/>
+                </a:solidFill>
+                <a:latin typeface="Calibri" pitchFamily="34" charset="0"/>
+                <a:ea typeface="Calibri" pitchFamily="34" charset="-122"/>
+                <a:cs typeface="Calibri" pitchFamily="34" charset="-120"/>
+              </a:rPr>
+              <a:t>From a terminal: </a:t>
+            </a:r>
+            <a:pPr indent="0" marL="0">
+              <a:buNone/>
+            </a:pPr>
+            <a:r>
+              <a:rPr lang="en-US" sz="1200" dirty="0">
+                <a:solidFill>
+                  <a:srgbClr val="8B9CFF"/>
+                </a:solidFill>
+                <a:latin typeface="Courier New" pitchFamily="34" charset="0"/>
+                <a:ea typeface="Courier New" pitchFamily="34" charset="-122"/>
+                <a:cs typeface="Courier New" pitchFamily="34" charset="-120"/>
+              </a:rPr>
+              <a:t>cd chain &amp;&amp; npm run verify:cycle:1</a:t>
+            </a:r>
+            <a:pPr indent="0" marL="0">
+              <a:buNone/>
+            </a:pPr>
+            <a:r>
+              <a:rPr lang="en-US" sz="1200" b="1" dirty="0">
+                <a:solidFill>
+                  <a:srgbClr val="22C55E"/>
+                </a:solidFill>
+                <a:latin typeface="Calibri" pitchFamily="34" charset="0"/>
+                <a:ea typeface="Calibri" pitchFamily="34" charset="-122"/>
+                <a:cs typeface="Calibri" pitchFamily="34" charset="-120"/>
+              </a:rPr>
+              <a:t>  →  MATCH</a:t>
+            </a:r>
+            <a:endParaRPr lang="en-US" sz="1200" dirty="0"/>
+          </a:p>
+        </p:txBody>
+      </p:sp>
+      <p:sp>
+        <p:nvSpPr>
+          <p:cNvPr id="32" name="Text 30"/>
+          <p:cNvSpPr/>
+          <p:nvPr/>
+        </p:nvSpPr>
+        <p:spPr>
+          <a:xfrm>
+            <a:off x="457200" y="4553712"/>
             <a:ext cx="8229600" cy="274320"/>
           </a:xfrm>
           <a:prstGeom prst="rect">

</xml_diff>

<commit_message>
docs: browser Verify + verify:cycle primary, audit secondary (archive RPC); on-chain counters 42/42; deck/FAQ/runbook aligned
Co-Authored-By: Claude Opus 5.5 <noreply@anthropic.com>
</commit_message>
<xml_diff>
--- a/docs/pitch/GRAIL-pitch.pptx
+++ b/docs/pitch/GRAIL-pitch.pptx
@@ -2024,7 +2024,7 @@
           <a:p>
             <a:r>
               <a:rPr lang="en-US" dirty="0"/>
-              <a:t>Puanın %35'i bu slaytta: otonomi. Döngü her 90 saniyede, kimse bir şeye tıklamadan çalışıyor. 4. ve 6. adımları göster: karar, emir daha ortada yokken Avalanche'a mühürleniyor; ajan piyasa cevap vermeden bağlanıyor. Beklemek de bir karar ve o da mühürleniyor. Zincirde 25+ döngü var, hepsi açılmış ve npm run audit ile hepsi eşleşiyor. İnsanın işi kuralları (ayarları) koymak, işlemleri onaylamak değil.</a:t>
+              <a:t>Puanın %35'i bu slaytta: otonomi. Döngü her 90 saniyede, kimse bir şeye tıklamadan çalışıyor. 4. ve 6. adımları göster: karar, emir daha ortada yokken Avalanche'a mühürleniyor; ajan piyasa cevap vermeden bağlanıyor. Beklemek de bir karar ve o da mühürleniyor. Zincirde 40+ döngü var, hepsi açılmış; her biri tarayıcıda "Verify yourself" ile ya da npm run verify:cycle ile kontrol edilebiliyor. İnsanın işi kuralları (ayarları) koymak, işlemleri onaylamak değil.</a:t>
             </a:r>
             <a:endParaRPr lang="en-US" dirty="0"/>
           </a:p>
@@ -4463,7 +4463,7 @@
                 <a:ea typeface="Courier New" pitchFamily="34" charset="-122"/>
                 <a:cs typeface="Courier New" pitchFamily="34" charset="-120"/>
               </a:rPr>
-              <a:t>cd chain &amp;&amp; npm run audit</a:t>
+              <a:t>cd chain &amp;&amp; npm run verify:cycle:1</a:t>
             </a:r>
             <a:pPr indent="0" marL="0">
               <a:buNone/>
@@ -4477,7 +4477,7 @@
                 <a:ea typeface="Calibri" pitchFamily="34" charset="-122"/>
                 <a:cs typeface="Calibri" pitchFamily="34" charset="-120"/>
               </a:rPr>
-              <a:t>  →  her döngü MATCH</a:t>
+              <a:t>  →  MATCH</a:t>
             </a:r>
             <a:endParaRPr lang="en-US" sz="1200" dirty="0"/>
           </a:p>
@@ -8494,7 +8494,7 @@
                 <a:ea typeface="Cambria" pitchFamily="34" charset="-122"/>
                 <a:cs typeface="Cambria" pitchFamily="34" charset="-120"/>
               </a:rPr>
-              <a:t>25+</a:t>
+              <a:t>40+</a:t>
             </a:r>
             <a:endParaRPr lang="en-US" sz="2800" dirty="0"/>
           </a:p>

</xml_diff>

<commit_message>
docs: audit back to primary proof (48/48 MATCH), live entry-gate evidence, regime-strategy slide ready for T-017
Co-Authored-By: Claude Opus 5.5 <noreply@anthropic.com>
</commit_message>
<xml_diff>
--- a/docs/pitch/GRAIL-pitch.pptx
+++ b/docs/pitch/GRAIL-pitch.pptx
@@ -1936,7 +1936,7 @@
           <a:p>
             <a:r>
               <a:rPr lang="en-US" dirty="0"/>
-              <a:t>Trend pozitif bir coin için bile hemen almıyoruz; iki kapıdan geçiyor. Birincisi: piyasa yatay mı? Bunu Hurst değeriyle TAHMİN ediyoruz. 48 saatlik veride bu tahmin gürültülü; o yüzden 'tespit' demiyoruz, bir temkin sinyali diyoruz. Yatay görünüyorsa momentum alımını bekletiyoruz. İkincisi: fiyat eski tepeyi kırdıysa, geri dönüp o seviyeyi test etmesini bekliyoruz; kırılım yoksa yarım boyut, kırılım ve geri test varsa tam boyut. En önemli kural: kapılar sadece azaltır. Bekleyen bir coini alıma çeviremez, bir alımı büyütemez, satışa dokunmaz. Aynı 30 günlük veride işlem sayısı 382'den 220'ye, en kötü düşüş %7,5'ten %4,3'e indi.</a:t>
+              <a:t>Ajan piyasanın rejimine göre davranışını seçiyor. Trend varsa momentum alımı; piyasa yatay görünüyorsa alım yapmadan bekliyor. Rejimi Hurst değeriyle TAHMİN ediyoruz; 48 saatlik veride bu tahmin gürültülü, rastgele veride bile yaklaşık %41 'yatay' çıkıyor. O yüzden 'tespit' demiyoruz. İkinci kapı: kırılım olduysa geri dönüp seviyeyi test etmesini bekliyoruz; kırılım yoksa yarım, kırılım ve geri test varsa tam boyut. Bugün canlıda, deneme modunda, aynı piyasa verisiyle: döngü başına alım 5'ten 1'e, tutar −%86. 4 coin yatay göründüğü için bekledi, ETH kırılım olmadığı için yarım boyutla alındı. Motor hatası 0, 48/48 döngünün hepsi zincirde. Dürüst not: 34 ile 44. döngüler arasında yapay zekâ sağlayıcısı kota nedeniyle cevap vermedi; kararlar değişmeden geçti (fail-open). 30 günlük tekrar oynatmada işlem sayısı 382'den 220'ye, en kötü düşüş %7,5'ten %4,3'e indi.</a:t>
             </a:r>
             <a:endParaRPr lang="en-US" dirty="0"/>
           </a:p>
@@ -2024,7 +2024,7 @@
           <a:p>
             <a:r>
               <a:rPr lang="en-US" dirty="0"/>
-              <a:t>Puanın %35'i bu slaytta: otonomi. Döngü her 90 saniyede, kimse bir şeye tıklamadan çalışıyor. 4. ve 6. adımları göster: karar, emir daha ortada yokken Avalanche'a mühürleniyor; ajan piyasa cevap vermeden bağlanıyor. Beklemek de bir karar ve o da mühürleniyor. Zincirde 40+ döngü var, hepsi açılmış; her biri tarayıcıda "Verify yourself" ile ya da npm run verify:cycle ile kontrol edilebiliyor. İnsanın işi kuralları (ayarları) koymak, işlemleri onaylamak değil.</a:t>
+              <a:t>Puanın %35'i bu slaytta: otonomi. Döngü her 90 saniyede, kimse bir şeye tıklamadan çalışıyor. 4. ve 6. adımları göster: karar, emir daha ortada yokken Avalanche'a mühürleniyor; ajan piyasa cevap vermeden bağlanıyor. Beklemek de bir karar ve o da mühürleniyor. Zincirde 48 döngü var, hepsi açılmış ve npm run audit ile hepsi eşleşiyor. İnsanın işi kuralları (ayarları) koymak, işlemleri onaylamak değil.</a:t>
             </a:r>
             <a:endParaRPr lang="en-US" dirty="0"/>
           </a:p>
@@ -4463,7 +4463,7 @@
                 <a:ea typeface="Courier New" pitchFamily="34" charset="-122"/>
                 <a:cs typeface="Courier New" pitchFamily="34" charset="-120"/>
               </a:rPr>
-              <a:t>cd chain &amp;&amp; npm run verify:cycle:1</a:t>
+              <a:t>cd chain &amp;&amp; npm run audit</a:t>
             </a:r>
             <a:pPr indent="0" marL="0">
               <a:buNone/>
@@ -4477,7 +4477,7 @@
                 <a:ea typeface="Calibri" pitchFamily="34" charset="-122"/>
                 <a:cs typeface="Calibri" pitchFamily="34" charset="-120"/>
               </a:rPr>
-              <a:t>  →  MATCH</a:t>
+              <a:t>  →  48/48 MATCH (~1–2 dk)</a:t>
             </a:r>
             <a:endParaRPr lang="en-US" sz="1200" dirty="0"/>
           </a:p>
@@ -7352,7 +7352,7 @@
                 <a:ea typeface="Cambria" pitchFamily="34" charset="-122"/>
                 <a:cs typeface="Cambria" pitchFamily="34" charset="-120"/>
               </a:rPr>
-              <a:t>Alımdan önce iki kapı</a:t>
+              <a:t>Rejime göre strateji seçimi</a:t>
             </a:r>
             <a:endParaRPr lang="en-US" sz="3000" dirty="0"/>
           </a:p>
@@ -7367,11 +7367,11 @@
         <p:spPr>
           <a:xfrm>
             <a:off x="457200" y="1325880"/>
-            <a:ext cx="3977640" cy="1234440"/>
+            <a:ext cx="3977640" cy="1600200"/>
           </a:xfrm>
           <a:prstGeom prst="roundRect">
             <a:avLst>
-              <a:gd name="adj" fmla="val 8889"/>
+              <a:gd name="adj" fmla="val 6857"/>
             </a:avLst>
           </a:prstGeom>
           <a:solidFill>
@@ -7393,7 +7393,7 @@
         </p:nvSpPr>
         <p:spPr>
           <a:xfrm>
-            <a:off x="640080" y="1490472"/>
+            <a:off x="640080" y="1463040"/>
             <a:ext cx="384048" cy="384048"/>
           </a:xfrm>
           <a:prstGeom prst="ellipse">
@@ -7418,7 +7418,7 @@
         </p:nvSpPr>
         <p:spPr>
           <a:xfrm>
-            <a:off x="640080" y="1490472"/>
+            <a:off x="640080" y="1463040"/>
             <a:ext cx="384048" cy="384048"/>
           </a:xfrm>
           <a:prstGeom prst="rect">
@@ -7457,24 +7457,24 @@
         </p:nvSpPr>
         <p:spPr>
           <a:xfrm>
-            <a:off x="1188720" y="1490472"/>
-            <a:ext cx="3108960" cy="384048"/>
-          </a:xfrm>
-          <a:prstGeom prst="rect">
-            <a:avLst/>
-          </a:prstGeom>
-          <a:noFill/>
-          <a:ln/>
-        </p:spPr>
-        <p:txBody>
-          <a:bodyPr wrap="square" lIns="0" tIns="0" rIns="0" bIns="0" rtlCol="0" anchor="ctr"/>
-          <a:lstStyle/>
-          <a:p>
-            <a:pPr indent="0" marL="0">
-              <a:buNone/>
-            </a:pPr>
-            <a:r>
-              <a:rPr lang="en-US" sz="1500" b="1" dirty="0">
+            <a:off x="1188720" y="1463040"/>
+            <a:ext cx="3154680" cy="384048"/>
+          </a:xfrm>
+          <a:prstGeom prst="rect">
+            <a:avLst/>
+          </a:prstGeom>
+          <a:noFill/>
+          <a:ln/>
+        </p:spPr>
+        <p:txBody>
+          <a:bodyPr wrap="square" lIns="0" tIns="0" rIns="0" bIns="0" rtlCol="0" anchor="ctr"/>
+          <a:lstStyle/>
+          <a:p>
+            <a:pPr indent="0" marL="0">
+              <a:buNone/>
+            </a:pPr>
+            <a:r>
+              <a:rPr lang="en-US" sz="1400" b="1" dirty="0">
                 <a:solidFill>
                   <a:srgbClr val="E6EAF2"/>
                 </a:solidFill>
@@ -7482,9 +7482,9 @@
                 <a:ea typeface="Calibri" pitchFamily="34" charset="-122"/>
                 <a:cs typeface="Calibri" pitchFamily="34" charset="-120"/>
               </a:rPr>
-              <a:t>Piyasa yatay mı? (Hurst)</a:t>
-            </a:r>
-            <a:endParaRPr lang="en-US" sz="1500" dirty="0"/>
+              <a:t>Piyasa trend mi, yatay mı? (Hurst)</a:t>
+            </a:r>
+            <a:endParaRPr lang="en-US" sz="1400" dirty="0"/>
           </a:p>
         </p:txBody>
       </p:sp>
@@ -7496,8 +7496,8 @@
         </p:nvSpPr>
         <p:spPr>
           <a:xfrm>
-            <a:off x="640080" y="1947672"/>
-            <a:ext cx="3657600" cy="566928"/>
+            <a:off x="640080" y="1920240"/>
+            <a:ext cx="3657600" cy="548640"/>
           </a:xfrm>
           <a:prstGeom prst="rect">
             <a:avLst/>
@@ -7513,7 +7513,91 @@
               <a:buNone/>
             </a:pPr>
             <a:r>
-              <a:rPr lang="en-US" sz="1100" dirty="0">
+              <a:rPr lang="en-US" sz="1300" b="1" dirty="0">
+                <a:solidFill>
+                  <a:srgbClr val="E8B04B"/>
+                </a:solidFill>
+                <a:latin typeface="Calibri" pitchFamily="34" charset="0"/>
+                <a:ea typeface="Calibri" pitchFamily="34" charset="-122"/>
+                <a:cs typeface="Calibri" pitchFamily="34" charset="-120"/>
+              </a:rPr>
+              <a:t>Trend → </a:t>
+            </a:r>
+            <a:pPr indent="0" marL="0">
+              <a:buNone/>
+            </a:pPr>
+            <a:r>
+              <a:rPr lang="en-US" sz="1300" dirty="0">
+                <a:solidFill>
+                  <a:srgbClr val="E6EAF2"/>
+                </a:solidFill>
+                <a:latin typeface="Calibri" pitchFamily="34" charset="0"/>
+                <a:ea typeface="Calibri" pitchFamily="34" charset="-122"/>
+                <a:cs typeface="Calibri" pitchFamily="34" charset="-120"/>
+              </a:rPr>
+              <a:t>momentum alımı</a:t>
+            </a:r>
+            <a:endParaRPr lang="en-US" sz="1300" dirty="0"/>
+          </a:p>
+          <a:p>
+            <a:pPr indent="0" marL="0">
+              <a:buNone/>
+            </a:pPr>
+            <a:r>
+              <a:rPr lang="en-US" sz="1300" b="1" dirty="0">
+                <a:solidFill>
+                  <a:srgbClr val="E8B04B"/>
+                </a:solidFill>
+                <a:latin typeface="Calibri" pitchFamily="34" charset="0"/>
+                <a:ea typeface="Calibri" pitchFamily="34" charset="-122"/>
+                <a:cs typeface="Calibri" pitchFamily="34" charset="-120"/>
+              </a:rPr>
+              <a:t>Yatay → </a:t>
+            </a:r>
+            <a:pPr indent="0" marL="0">
+              <a:buNone/>
+            </a:pPr>
+            <a:r>
+              <a:rPr lang="en-US" sz="1300" dirty="0">
+                <a:solidFill>
+                  <a:srgbClr val="E6EAF2"/>
+                </a:solidFill>
+                <a:latin typeface="Calibri" pitchFamily="34" charset="0"/>
+                <a:ea typeface="Calibri" pitchFamily="34" charset="-122"/>
+                <a:cs typeface="Calibri" pitchFamily="34" charset="-120"/>
+              </a:rPr>
+              <a:t>bekler, alım yapmaz</a:t>
+            </a:r>
+            <a:endParaRPr lang="en-US" sz="1300" dirty="0"/>
+          </a:p>
+        </p:txBody>
+      </p:sp>
+      <p:sp>
+        <p:nvSpPr>
+          <p:cNvPr id="9" name="Text 7"/>
+          <p:cNvSpPr/>
+          <p:nvPr/>
+        </p:nvSpPr>
+        <p:spPr>
+          <a:xfrm>
+            <a:off x="640080" y="2514600"/>
+            <a:ext cx="3657600" cy="365760"/>
+          </a:xfrm>
+          <a:prstGeom prst="rect">
+            <a:avLst/>
+          </a:prstGeom>
+          <a:noFill/>
+          <a:ln/>
+        </p:spPr>
+        <p:txBody>
+          <a:bodyPr wrap="square" lIns="0" tIns="0" rIns="0" bIns="0" rtlCol="0" anchor="t"/>
+          <a:lstStyle/>
+          <a:p>
+            <a:pPr indent="0" marL="0">
+              <a:buNone/>
+            </a:pPr>
+            <a:r>
+              <a:rPr lang="en-US" sz="1000" i="1" dirty="0">
                 <a:solidFill>
                   <a:srgbClr val="8A94A8"/>
                 </a:solidFill>
@@ -7521,26 +7605,26 @@
                 <a:ea typeface="Calibri" pitchFamily="34" charset="-122"/>
                 <a:cs typeface="Calibri" pitchFamily="34" charset="-120"/>
               </a:rPr>
-              <a:t>Son 48 saatlik fiyattan bir tahmin: fiyat bir yöne mi gidiyor, yoksa bir aşağı bir yukarı mı? Kısa geçmişte gürültülüdür; kesin tespit değil, temkin sinyalidir.</a:t>
-            </a:r>
-            <a:endParaRPr lang="en-US" sz="1100" dirty="0"/>
-          </a:p>
-        </p:txBody>
-      </p:sp>
-      <p:sp>
-        <p:nvSpPr>
-          <p:cNvPr id="9" name="Shape 7"/>
-          <p:cNvSpPr/>
-          <p:nvPr/>
-        </p:nvSpPr>
-        <p:spPr>
-          <a:xfrm>
-            <a:off x="457200" y="2697480"/>
-            <a:ext cx="3977640" cy="1234440"/>
+              <a:t>48 barlık Hurst bir tahmindir; rastgele veride de ~%41 "yatay" çıkar.</a:t>
+            </a:r>
+            <a:endParaRPr lang="en-US" sz="1000" dirty="0"/>
+          </a:p>
+        </p:txBody>
+      </p:sp>
+      <p:sp>
+        <p:nvSpPr>
+          <p:cNvPr id="10" name="Shape 8"/>
+          <p:cNvSpPr/>
+          <p:nvPr/>
+        </p:nvSpPr>
+        <p:spPr>
+          <a:xfrm>
+            <a:off x="457200" y="3063240"/>
+            <a:ext cx="3977640" cy="914400"/>
           </a:xfrm>
           <a:prstGeom prst="roundRect">
             <a:avLst>
-              <a:gd name="adj" fmla="val 8889"/>
+              <a:gd name="adj" fmla="val 12000"/>
             </a:avLst>
           </a:prstGeom>
           <a:solidFill>
@@ -7556,13 +7640,13 @@
       </p:sp>
       <p:sp>
         <p:nvSpPr>
-          <p:cNvPr id="10" name="Shape 8"/>
-          <p:cNvSpPr/>
-          <p:nvPr/>
-        </p:nvSpPr>
-        <p:spPr>
-          <a:xfrm>
-            <a:off x="640080" y="2862072"/>
+          <p:cNvPr id="11" name="Shape 9"/>
+          <p:cNvSpPr/>
+          <p:nvPr/>
+        </p:nvSpPr>
+        <p:spPr>
+          <a:xfrm>
+            <a:off x="640080" y="3200400"/>
             <a:ext cx="384048" cy="384048"/>
           </a:xfrm>
           <a:prstGeom prst="ellipse">
@@ -7581,13 +7665,13 @@
       </p:sp>
       <p:sp>
         <p:nvSpPr>
-          <p:cNvPr id="11" name="Text 9"/>
-          <p:cNvSpPr/>
-          <p:nvPr/>
-        </p:nvSpPr>
-        <p:spPr>
-          <a:xfrm>
-            <a:off x="640080" y="2862072"/>
+          <p:cNvPr id="12" name="Text 10"/>
+          <p:cNvSpPr/>
+          <p:nvPr/>
+        </p:nvSpPr>
+        <p:spPr>
+          <a:xfrm>
+            <a:off x="640080" y="3200400"/>
             <a:ext cx="384048" cy="384048"/>
           </a:xfrm>
           <a:prstGeom prst="rect">
@@ -7620,30 +7704,30 @@
       </p:sp>
       <p:sp>
         <p:nvSpPr>
-          <p:cNvPr id="12" name="Text 10"/>
-          <p:cNvSpPr/>
-          <p:nvPr/>
-        </p:nvSpPr>
-        <p:spPr>
-          <a:xfrm>
-            <a:off x="1188720" y="2862072"/>
-            <a:ext cx="3108960" cy="384048"/>
-          </a:xfrm>
-          <a:prstGeom prst="rect">
-            <a:avLst/>
-          </a:prstGeom>
-          <a:noFill/>
-          <a:ln/>
-        </p:spPr>
-        <p:txBody>
-          <a:bodyPr wrap="square" lIns="0" tIns="0" rIns="0" bIns="0" rtlCol="0" anchor="ctr"/>
-          <a:lstStyle/>
-          <a:p>
-            <a:pPr indent="0" marL="0">
-              <a:buNone/>
-            </a:pPr>
-            <a:r>
-              <a:rPr lang="en-US" sz="1500" b="1" dirty="0">
+          <p:cNvPr id="13" name="Text 11"/>
+          <p:cNvSpPr/>
+          <p:nvPr/>
+        </p:nvSpPr>
+        <p:spPr>
+          <a:xfrm>
+            <a:off x="1188720" y="3200400"/>
+            <a:ext cx="3154680" cy="384048"/>
+          </a:xfrm>
+          <a:prstGeom prst="rect">
+            <a:avLst/>
+          </a:prstGeom>
+          <a:noFill/>
+          <a:ln/>
+        </p:spPr>
+        <p:txBody>
+          <a:bodyPr wrap="square" lIns="0" tIns="0" rIns="0" bIns="0" rtlCol="0" anchor="ctr"/>
+          <a:lstStyle/>
+          <a:p>
+            <a:pPr indent="0" marL="0">
+              <a:buNone/>
+            </a:pPr>
+            <a:r>
+              <a:rPr lang="en-US" sz="1400" b="1" dirty="0">
                 <a:solidFill>
                   <a:srgbClr val="E6EAF2"/>
                 </a:solidFill>
@@ -7653,20 +7737,20 @@
               </a:rPr>
               <a:t>Kırılım geri test edildi mi?</a:t>
             </a:r>
-            <a:endParaRPr lang="en-US" sz="1500" dirty="0"/>
-          </a:p>
-        </p:txBody>
-      </p:sp>
-      <p:sp>
-        <p:nvSpPr>
-          <p:cNvPr id="13" name="Text 11"/>
-          <p:cNvSpPr/>
-          <p:nvPr/>
-        </p:nvSpPr>
-        <p:spPr>
-          <a:xfrm>
-            <a:off x="640080" y="3319272"/>
-            <a:ext cx="3657600" cy="566928"/>
+            <a:endParaRPr lang="en-US" sz="1400" dirty="0"/>
+          </a:p>
+        </p:txBody>
+      </p:sp>
+      <p:sp>
+        <p:nvSpPr>
+          <p:cNvPr id="14" name="Text 12"/>
+          <p:cNvSpPr/>
+          <p:nvPr/>
+        </p:nvSpPr>
+        <p:spPr>
+          <a:xfrm>
+            <a:off x="640080" y="3630168"/>
+            <a:ext cx="3657600" cy="320040"/>
           </a:xfrm>
           <a:prstGeom prst="rect">
             <a:avLst/>
@@ -7690,7 +7774,7 @@
                 <a:ea typeface="Calibri" pitchFamily="34" charset="-122"/>
                 <a:cs typeface="Calibri" pitchFamily="34" charset="-120"/>
               </a:rPr>
-              <a:t>Fiyat eski tepeyi aştıysa, alımdan önce o seviyeye geri dönüp tutunmasını bekler.</a:t>
+              <a:t>Eski tepe aşıldıysa, alımdan önce geri dönüp tutunmasını bekler.</a:t>
             </a:r>
             <a:endParaRPr lang="en-US" sz="1100" dirty="0"/>
           </a:p>
@@ -7698,18 +7782,18 @@
       </p:sp>
       <p:sp>
         <p:nvSpPr>
-          <p:cNvPr id="14" name="Shape 12"/>
+          <p:cNvPr id="15" name="Shape 13"/>
           <p:cNvSpPr/>
           <p:nvPr/>
         </p:nvSpPr>
         <p:spPr>
           <a:xfrm>
             <a:off x="4663440" y="1325880"/>
-            <a:ext cx="3977640" cy="2606040"/>
+            <a:ext cx="3977640" cy="1600200"/>
           </a:xfrm>
           <a:prstGeom prst="roundRect">
             <a:avLst>
-              <a:gd name="adj" fmla="val 4211"/>
+              <a:gd name="adj" fmla="val 6857"/>
             </a:avLst>
           </a:prstGeom>
           <a:solidFill>
@@ -7725,30 +7809,30 @@
       </p:sp>
       <p:sp>
         <p:nvSpPr>
-          <p:cNvPr id="15" name="Text 13"/>
-          <p:cNvSpPr/>
-          <p:nvPr/>
-        </p:nvSpPr>
-        <p:spPr>
-          <a:xfrm>
-            <a:off x="4892040" y="1463040"/>
-            <a:ext cx="3566160" cy="320040"/>
-          </a:xfrm>
-          <a:prstGeom prst="rect">
-            <a:avLst/>
-          </a:prstGeom>
-          <a:noFill/>
-          <a:ln/>
-        </p:spPr>
-        <p:txBody>
-          <a:bodyPr wrap="square" lIns="0" tIns="0" rIns="0" bIns="0" rtlCol="0" anchor="ctr"/>
-          <a:lstStyle/>
-          <a:p>
-            <a:pPr indent="0" marL="0">
-              <a:buNone/>
-            </a:pPr>
-            <a:r>
-              <a:rPr lang="en-US" sz="1300" b="1" dirty="0">
+          <p:cNvPr id="16" name="Text 14"/>
+          <p:cNvSpPr/>
+          <p:nvPr/>
+        </p:nvSpPr>
+        <p:spPr>
+          <a:xfrm>
+            <a:off x="4846320" y="1389888"/>
+            <a:ext cx="3566160" cy="274320"/>
+          </a:xfrm>
+          <a:prstGeom prst="rect">
+            <a:avLst/>
+          </a:prstGeom>
+          <a:noFill/>
+          <a:ln/>
+        </p:spPr>
+        <p:txBody>
+          <a:bodyPr wrap="square" lIns="0" tIns="0" rIns="0" bIns="0" rtlCol="0" anchor="ctr"/>
+          <a:lstStyle/>
+          <a:p>
+            <a:pPr indent="0" marL="0">
+              <a:buNone/>
+            </a:pPr>
+            <a:r>
+              <a:rPr lang="en-US" sz="1200" b="1" dirty="0">
                 <a:solidFill>
                   <a:srgbClr val="E8B04B"/>
                 </a:solidFill>
@@ -7758,20 +7842,20 @@
               </a:rPr>
               <a:t>Durum → alım büyüklüğü</a:t>
             </a:r>
-            <a:endParaRPr lang="en-US" sz="1300" dirty="0"/>
-          </a:p>
-        </p:txBody>
-      </p:sp>
-      <p:sp>
-        <p:nvSpPr>
-          <p:cNvPr id="16" name="Shape 14"/>
-          <p:cNvSpPr/>
-          <p:nvPr/>
-        </p:nvSpPr>
-        <p:spPr>
-          <a:xfrm>
-            <a:off x="4892040" y="1837944"/>
-            <a:ext cx="3566160" cy="0"/>
+            <a:endParaRPr lang="en-US" sz="1200" dirty="0"/>
+          </a:p>
+        </p:txBody>
+      </p:sp>
+      <p:sp>
+        <p:nvSpPr>
+          <p:cNvPr id="17" name="Shape 15"/>
+          <p:cNvSpPr/>
+          <p:nvPr/>
+        </p:nvSpPr>
+        <p:spPr>
+          <a:xfrm>
+            <a:off x="4846320" y="1682496"/>
+            <a:ext cx="3611880" cy="0"/>
           </a:xfrm>
           <a:prstGeom prst="line">
             <a:avLst/>
@@ -7787,30 +7871,30 @@
       </p:sp>
       <p:sp>
         <p:nvSpPr>
-          <p:cNvPr id="17" name="Text 15"/>
-          <p:cNvSpPr/>
-          <p:nvPr/>
-        </p:nvSpPr>
-        <p:spPr>
-          <a:xfrm>
-            <a:off x="4892040" y="1874520"/>
-            <a:ext cx="2514600" cy="420624"/>
-          </a:xfrm>
-          <a:prstGeom prst="rect">
-            <a:avLst/>
-          </a:prstGeom>
-          <a:noFill/>
-          <a:ln/>
-        </p:spPr>
-        <p:txBody>
-          <a:bodyPr wrap="square" lIns="0" tIns="0" rIns="0" bIns="0" rtlCol="0" anchor="ctr"/>
-          <a:lstStyle/>
-          <a:p>
-            <a:pPr indent="0" marL="0">
-              <a:buNone/>
-            </a:pPr>
-            <a:r>
-              <a:rPr lang="en-US" sz="1200" dirty="0">
+          <p:cNvPr id="18" name="Text 16"/>
+          <p:cNvSpPr/>
+          <p:nvPr/>
+        </p:nvSpPr>
+        <p:spPr>
+          <a:xfrm>
+            <a:off x="4846320" y="1700784"/>
+            <a:ext cx="2377440" cy="274320"/>
+          </a:xfrm>
+          <a:prstGeom prst="rect">
+            <a:avLst/>
+          </a:prstGeom>
+          <a:noFill/>
+          <a:ln/>
+        </p:spPr>
+        <p:txBody>
+          <a:bodyPr wrap="square" lIns="0" tIns="0" rIns="0" bIns="0" rtlCol="0" anchor="ctr"/>
+          <a:lstStyle/>
+          <a:p>
+            <a:pPr indent="0" marL="0">
+              <a:buNone/>
+            </a:pPr>
+            <a:r>
+              <a:rPr lang="en-US" sz="1100" dirty="0">
                 <a:solidFill>
                   <a:srgbClr val="E6EAF2"/>
                 </a:solidFill>
@@ -7818,22 +7902,22 @@
                 <a:ea typeface="Calibri" pitchFamily="34" charset="-122"/>
                 <a:cs typeface="Calibri" pitchFamily="34" charset="-120"/>
               </a:rPr>
-              <a:t>Piyasa yatay görünüyor (Hurst &lt; 0,45)</a:t>
-            </a:r>
-            <a:endParaRPr lang="en-US" sz="1200" dirty="0"/>
-          </a:p>
-        </p:txBody>
-      </p:sp>
-      <p:sp>
-        <p:nvSpPr>
-          <p:cNvPr id="18" name="Text 16"/>
-          <p:cNvSpPr/>
-          <p:nvPr/>
-        </p:nvSpPr>
-        <p:spPr>
-          <a:xfrm>
-            <a:off x="7406640" y="1874520"/>
-            <a:ext cx="1051560" cy="420624"/>
+              <a:t>Yatay görünüyor (Hurst &lt; 0,45)</a:t>
+            </a:r>
+            <a:endParaRPr lang="en-US" sz="1100" dirty="0"/>
+          </a:p>
+        </p:txBody>
+      </p:sp>
+      <p:sp>
+        <p:nvSpPr>
+          <p:cNvPr id="19" name="Text 17"/>
+          <p:cNvSpPr/>
+          <p:nvPr/>
+        </p:nvSpPr>
+        <p:spPr>
+          <a:xfrm>
+            <a:off x="7178040" y="1700784"/>
+            <a:ext cx="1280160" cy="274320"/>
           </a:xfrm>
           <a:prstGeom prst="rect">
             <a:avLst/>
@@ -7849,7 +7933,7 @@
               <a:buNone/>
             </a:pPr>
             <a:r>
-              <a:rPr lang="en-US" sz="1300" b="1" dirty="0">
+              <a:rPr lang="en-US" sz="1100" b="1" dirty="0">
                 <a:solidFill>
                   <a:srgbClr val="8A94A8"/>
                 </a:solidFill>
@@ -7859,20 +7943,20 @@
               </a:rPr>
               <a:t>0 · bekle</a:t>
             </a:r>
-            <a:endParaRPr lang="en-US" sz="1300" dirty="0"/>
-          </a:p>
-        </p:txBody>
-      </p:sp>
-      <p:sp>
-        <p:nvSpPr>
-          <p:cNvPr id="19" name="Shape 17"/>
-          <p:cNvSpPr/>
-          <p:nvPr/>
-        </p:nvSpPr>
-        <p:spPr>
-          <a:xfrm>
-            <a:off x="4892040" y="2340864"/>
-            <a:ext cx="3566160" cy="0"/>
+            <a:endParaRPr lang="en-US" sz="1100" dirty="0"/>
+          </a:p>
+        </p:txBody>
+      </p:sp>
+      <p:sp>
+        <p:nvSpPr>
+          <p:cNvPr id="20" name="Shape 18"/>
+          <p:cNvSpPr/>
+          <p:nvPr/>
+        </p:nvSpPr>
+        <p:spPr>
+          <a:xfrm>
+            <a:off x="4846320" y="1975104"/>
+            <a:ext cx="3611880" cy="0"/>
           </a:xfrm>
           <a:prstGeom prst="line">
             <a:avLst/>
@@ -7888,30 +7972,30 @@
       </p:sp>
       <p:sp>
         <p:nvSpPr>
-          <p:cNvPr id="20" name="Text 18"/>
-          <p:cNvSpPr/>
-          <p:nvPr/>
-        </p:nvSpPr>
-        <p:spPr>
-          <a:xfrm>
-            <a:off x="4892040" y="2377440"/>
-            <a:ext cx="2514600" cy="420624"/>
-          </a:xfrm>
-          <a:prstGeom prst="rect">
-            <a:avLst/>
-          </a:prstGeom>
-          <a:noFill/>
-          <a:ln/>
-        </p:spPr>
-        <p:txBody>
-          <a:bodyPr wrap="square" lIns="0" tIns="0" rIns="0" bIns="0" rtlCol="0" anchor="ctr"/>
-          <a:lstStyle/>
-          <a:p>
-            <a:pPr indent="0" marL="0">
-              <a:buNone/>
-            </a:pPr>
-            <a:r>
-              <a:rPr lang="en-US" sz="1200" dirty="0">
+          <p:cNvPr id="21" name="Text 19"/>
+          <p:cNvSpPr/>
+          <p:nvPr/>
+        </p:nvSpPr>
+        <p:spPr>
+          <a:xfrm>
+            <a:off x="4846320" y="1993392"/>
+            <a:ext cx="2377440" cy="274320"/>
+          </a:xfrm>
+          <a:prstGeom prst="rect">
+            <a:avLst/>
+          </a:prstGeom>
+          <a:noFill/>
+          <a:ln/>
+        </p:spPr>
+        <p:txBody>
+          <a:bodyPr wrap="square" lIns="0" tIns="0" rIns="0" bIns="0" rtlCol="0" anchor="ctr"/>
+          <a:lstStyle/>
+          <a:p>
+            <a:pPr indent="0" marL="0">
+              <a:buNone/>
+            </a:pPr>
+            <a:r>
+              <a:rPr lang="en-US" sz="1100" dirty="0">
                 <a:solidFill>
                   <a:srgbClr val="E6EAF2"/>
                 </a:solidFill>
@@ -7921,20 +8005,20 @@
               </a:rPr>
               <a:t>Kırılım var, geri test yok</a:t>
             </a:r>
-            <a:endParaRPr lang="en-US" sz="1200" dirty="0"/>
-          </a:p>
-        </p:txBody>
-      </p:sp>
-      <p:sp>
-        <p:nvSpPr>
-          <p:cNvPr id="21" name="Text 19"/>
-          <p:cNvSpPr/>
-          <p:nvPr/>
-        </p:nvSpPr>
-        <p:spPr>
-          <a:xfrm>
-            <a:off x="7406640" y="2377440"/>
-            <a:ext cx="1051560" cy="420624"/>
+            <a:endParaRPr lang="en-US" sz="1100" dirty="0"/>
+          </a:p>
+        </p:txBody>
+      </p:sp>
+      <p:sp>
+        <p:nvSpPr>
+          <p:cNvPr id="22" name="Text 20"/>
+          <p:cNvSpPr/>
+          <p:nvPr/>
+        </p:nvSpPr>
+        <p:spPr>
+          <a:xfrm>
+            <a:off x="7178040" y="1993392"/>
+            <a:ext cx="1280160" cy="274320"/>
           </a:xfrm>
           <a:prstGeom prst="rect">
             <a:avLst/>
@@ -7950,7 +8034,7 @@
               <a:buNone/>
             </a:pPr>
             <a:r>
-              <a:rPr lang="en-US" sz="1300" b="1" dirty="0">
+              <a:rPr lang="en-US" sz="1100" b="1" dirty="0">
                 <a:solidFill>
                   <a:srgbClr val="8A94A8"/>
                 </a:solidFill>
@@ -7960,20 +8044,20 @@
               </a:rPr>
               <a:t>0 · bekle</a:t>
             </a:r>
-            <a:endParaRPr lang="en-US" sz="1300" dirty="0"/>
-          </a:p>
-        </p:txBody>
-      </p:sp>
-      <p:sp>
-        <p:nvSpPr>
-          <p:cNvPr id="22" name="Shape 20"/>
-          <p:cNvSpPr/>
-          <p:nvPr/>
-        </p:nvSpPr>
-        <p:spPr>
-          <a:xfrm>
-            <a:off x="4892040" y="2843784"/>
-            <a:ext cx="3566160" cy="0"/>
+            <a:endParaRPr lang="en-US" sz="1100" dirty="0"/>
+          </a:p>
+        </p:txBody>
+      </p:sp>
+      <p:sp>
+        <p:nvSpPr>
+          <p:cNvPr id="23" name="Shape 21"/>
+          <p:cNvSpPr/>
+          <p:nvPr/>
+        </p:nvSpPr>
+        <p:spPr>
+          <a:xfrm>
+            <a:off x="4846320" y="2267712"/>
+            <a:ext cx="3611880" cy="0"/>
           </a:xfrm>
           <a:prstGeom prst="line">
             <a:avLst/>
@@ -7989,30 +8073,30 @@
       </p:sp>
       <p:sp>
         <p:nvSpPr>
-          <p:cNvPr id="23" name="Text 21"/>
-          <p:cNvSpPr/>
-          <p:nvPr/>
-        </p:nvSpPr>
-        <p:spPr>
-          <a:xfrm>
-            <a:off x="4892040" y="2880360"/>
-            <a:ext cx="2514600" cy="420624"/>
-          </a:xfrm>
-          <a:prstGeom prst="rect">
-            <a:avLst/>
-          </a:prstGeom>
-          <a:noFill/>
-          <a:ln/>
-        </p:spPr>
-        <p:txBody>
-          <a:bodyPr wrap="square" lIns="0" tIns="0" rIns="0" bIns="0" rtlCol="0" anchor="ctr"/>
-          <a:lstStyle/>
-          <a:p>
-            <a:pPr indent="0" marL="0">
-              <a:buNone/>
-            </a:pPr>
-            <a:r>
-              <a:rPr lang="en-US" sz="1200" dirty="0">
+          <p:cNvPr id="24" name="Text 22"/>
+          <p:cNvSpPr/>
+          <p:nvPr/>
+        </p:nvSpPr>
+        <p:spPr>
+          <a:xfrm>
+            <a:off x="4846320" y="2286000"/>
+            <a:ext cx="2377440" cy="274320"/>
+          </a:xfrm>
+          <a:prstGeom prst="rect">
+            <a:avLst/>
+          </a:prstGeom>
+          <a:noFill/>
+          <a:ln/>
+        </p:spPr>
+        <p:txBody>
+          <a:bodyPr wrap="square" lIns="0" tIns="0" rIns="0" bIns="0" rtlCol="0" anchor="ctr"/>
+          <a:lstStyle/>
+          <a:p>
+            <a:pPr indent="0" marL="0">
+              <a:buNone/>
+            </a:pPr>
+            <a:r>
+              <a:rPr lang="en-US" sz="1100" dirty="0">
                 <a:solidFill>
                   <a:srgbClr val="E6EAF2"/>
                 </a:solidFill>
@@ -8022,20 +8106,20 @@
               </a:rPr>
               <a:t>Henüz kırılım yok</a:t>
             </a:r>
-            <a:endParaRPr lang="en-US" sz="1200" dirty="0"/>
-          </a:p>
-        </p:txBody>
-      </p:sp>
-      <p:sp>
-        <p:nvSpPr>
-          <p:cNvPr id="24" name="Text 22"/>
-          <p:cNvSpPr/>
-          <p:nvPr/>
-        </p:nvSpPr>
-        <p:spPr>
-          <a:xfrm>
-            <a:off x="7406640" y="2880360"/>
-            <a:ext cx="1051560" cy="420624"/>
+            <a:endParaRPr lang="en-US" sz="1100" dirty="0"/>
+          </a:p>
+        </p:txBody>
+      </p:sp>
+      <p:sp>
+        <p:nvSpPr>
+          <p:cNvPr id="25" name="Text 23"/>
+          <p:cNvSpPr/>
+          <p:nvPr/>
+        </p:nvSpPr>
+        <p:spPr>
+          <a:xfrm>
+            <a:off x="7178040" y="2286000"/>
+            <a:ext cx="1280160" cy="274320"/>
           </a:xfrm>
           <a:prstGeom prst="rect">
             <a:avLst/>
@@ -8051,7 +8135,7 @@
               <a:buNone/>
             </a:pPr>
             <a:r>
-              <a:rPr lang="en-US" sz="1300" b="1" dirty="0">
+              <a:rPr lang="en-US" sz="1100" b="1" dirty="0">
                 <a:solidFill>
                   <a:srgbClr val="E6EAF2"/>
                 </a:solidFill>
@@ -8061,20 +8145,20 @@
               </a:rPr>
               <a:t>yarım</a:t>
             </a:r>
-            <a:endParaRPr lang="en-US" sz="1300" dirty="0"/>
-          </a:p>
-        </p:txBody>
-      </p:sp>
-      <p:sp>
-        <p:nvSpPr>
-          <p:cNvPr id="25" name="Shape 23"/>
-          <p:cNvSpPr/>
-          <p:nvPr/>
-        </p:nvSpPr>
-        <p:spPr>
-          <a:xfrm>
-            <a:off x="4892040" y="3346704"/>
-            <a:ext cx="3566160" cy="0"/>
+            <a:endParaRPr lang="en-US" sz="1100" dirty="0"/>
+          </a:p>
+        </p:txBody>
+      </p:sp>
+      <p:sp>
+        <p:nvSpPr>
+          <p:cNvPr id="26" name="Shape 24"/>
+          <p:cNvSpPr/>
+          <p:nvPr/>
+        </p:nvSpPr>
+        <p:spPr>
+          <a:xfrm>
+            <a:off x="4846320" y="2560320"/>
+            <a:ext cx="3611880" cy="0"/>
           </a:xfrm>
           <a:prstGeom prst="line">
             <a:avLst/>
@@ -8090,30 +8174,30 @@
       </p:sp>
       <p:sp>
         <p:nvSpPr>
-          <p:cNvPr id="26" name="Text 24"/>
-          <p:cNvSpPr/>
-          <p:nvPr/>
-        </p:nvSpPr>
-        <p:spPr>
-          <a:xfrm>
-            <a:off x="4892040" y="3383280"/>
-            <a:ext cx="2514600" cy="420624"/>
-          </a:xfrm>
-          <a:prstGeom prst="rect">
-            <a:avLst/>
-          </a:prstGeom>
-          <a:noFill/>
-          <a:ln/>
-        </p:spPr>
-        <p:txBody>
-          <a:bodyPr wrap="square" lIns="0" tIns="0" rIns="0" bIns="0" rtlCol="0" anchor="ctr"/>
-          <a:lstStyle/>
-          <a:p>
-            <a:pPr indent="0" marL="0">
-              <a:buNone/>
-            </a:pPr>
-            <a:r>
-              <a:rPr lang="en-US" sz="1200" dirty="0">
+          <p:cNvPr id="27" name="Text 25"/>
+          <p:cNvSpPr/>
+          <p:nvPr/>
+        </p:nvSpPr>
+        <p:spPr>
+          <a:xfrm>
+            <a:off x="4846320" y="2578608"/>
+            <a:ext cx="2377440" cy="274320"/>
+          </a:xfrm>
+          <a:prstGeom prst="rect">
+            <a:avLst/>
+          </a:prstGeom>
+          <a:noFill/>
+          <a:ln/>
+        </p:spPr>
+        <p:txBody>
+          <a:bodyPr wrap="square" lIns="0" tIns="0" rIns="0" bIns="0" rtlCol="0" anchor="ctr"/>
+          <a:lstStyle/>
+          <a:p>
+            <a:pPr indent="0" marL="0">
+              <a:buNone/>
+            </a:pPr>
+            <a:r>
+              <a:rPr lang="en-US" sz="1100" dirty="0">
                 <a:solidFill>
                   <a:srgbClr val="E6EAF2"/>
                 </a:solidFill>
@@ -8123,20 +8207,20 @@
               </a:rPr>
               <a:t>Kırılım + geri test</a:t>
             </a:r>
-            <a:endParaRPr lang="en-US" sz="1200" dirty="0"/>
-          </a:p>
-        </p:txBody>
-      </p:sp>
-      <p:sp>
-        <p:nvSpPr>
-          <p:cNvPr id="27" name="Text 25"/>
-          <p:cNvSpPr/>
-          <p:nvPr/>
-        </p:nvSpPr>
-        <p:spPr>
-          <a:xfrm>
-            <a:off x="7406640" y="3383280"/>
-            <a:ext cx="1051560" cy="420624"/>
+            <a:endParaRPr lang="en-US" sz="1100" dirty="0"/>
+          </a:p>
+        </p:txBody>
+      </p:sp>
+      <p:sp>
+        <p:nvSpPr>
+          <p:cNvPr id="28" name="Text 26"/>
+          <p:cNvSpPr/>
+          <p:nvPr/>
+        </p:nvSpPr>
+        <p:spPr>
+          <a:xfrm>
+            <a:off x="7178040" y="2578608"/>
+            <a:ext cx="1280160" cy="274320"/>
           </a:xfrm>
           <a:prstGeom prst="rect">
             <a:avLst/>
@@ -8152,7 +8236,7 @@
               <a:buNone/>
             </a:pPr>
             <a:r>
-              <a:rPr lang="en-US" sz="1300" b="1" dirty="0">
+              <a:rPr lang="en-US" sz="1100" b="1" dirty="0">
                 <a:solidFill>
                   <a:srgbClr val="22C55E"/>
                 </a:solidFill>
@@ -8162,24 +8246,24 @@
               </a:rPr>
               <a:t>tam</a:t>
             </a:r>
-            <a:endParaRPr lang="en-US" sz="1300" dirty="0"/>
-          </a:p>
-        </p:txBody>
-      </p:sp>
-      <p:sp>
-        <p:nvSpPr>
-          <p:cNvPr id="28" name="Shape 26"/>
-          <p:cNvSpPr/>
-          <p:nvPr/>
-        </p:nvSpPr>
-        <p:spPr>
-          <a:xfrm>
-            <a:off x="457200" y="4114800"/>
-            <a:ext cx="8183880" cy="640080"/>
+            <a:endParaRPr lang="en-US" sz="1100" dirty="0"/>
+          </a:p>
+        </p:txBody>
+      </p:sp>
+      <p:sp>
+        <p:nvSpPr>
+          <p:cNvPr id="29" name="Shape 27"/>
+          <p:cNvSpPr/>
+          <p:nvPr/>
+        </p:nvSpPr>
+        <p:spPr>
+          <a:xfrm>
+            <a:off x="4663440" y="3063240"/>
+            <a:ext cx="3977640" cy="914400"/>
           </a:xfrm>
           <a:prstGeom prst="roundRect">
             <a:avLst>
-              <a:gd name="adj" fmla="val 17143"/>
+              <a:gd name="adj" fmla="val 12000"/>
             </a:avLst>
           </a:prstGeom>
           <a:solidFill>
@@ -8195,7 +8279,151 @@
       </p:sp>
       <p:sp>
         <p:nvSpPr>
-          <p:cNvPr id="29" name="Text 27"/>
+          <p:cNvPr id="30" name="Text 28"/>
+          <p:cNvSpPr/>
+          <p:nvPr/>
+        </p:nvSpPr>
+        <p:spPr>
+          <a:xfrm>
+            <a:off x="4846320" y="3127248"/>
+            <a:ext cx="3657600" cy="228600"/>
+          </a:xfrm>
+          <a:prstGeom prst="rect">
+            <a:avLst/>
+          </a:prstGeom>
+          <a:noFill/>
+          <a:ln/>
+        </p:spPr>
+        <p:txBody>
+          <a:bodyPr wrap="square" lIns="0" tIns="0" rIns="0" bIns="0" rtlCol="0" anchor="ctr"/>
+          <a:lstStyle/>
+          <a:p>
+            <a:pPr indent="0" marL="0">
+              <a:buNone/>
+            </a:pPr>
+            <a:r>
+              <a:rPr lang="en-US" sz="1100" b="1" dirty="0">
+                <a:solidFill>
+                  <a:srgbClr val="E8B04B"/>
+                </a:solidFill>
+                <a:latin typeface="Calibri" pitchFamily="34" charset="0"/>
+                <a:ea typeface="Calibri" pitchFamily="34" charset="-122"/>
+                <a:cs typeface="Calibri" pitchFamily="34" charset="-120"/>
+              </a:rPr>
+              <a:t>Bugün canlıda (deneme modu, aynı piyasa verisi)</a:t>
+            </a:r>
+            <a:endParaRPr lang="en-US" sz="1100" dirty="0"/>
+          </a:p>
+        </p:txBody>
+      </p:sp>
+      <p:sp>
+        <p:nvSpPr>
+          <p:cNvPr id="31" name="Text 29"/>
+          <p:cNvSpPr/>
+          <p:nvPr/>
+        </p:nvSpPr>
+        <p:spPr>
+          <a:xfrm>
+            <a:off x="4846320" y="3355848"/>
+            <a:ext cx="3657600" cy="384048"/>
+          </a:xfrm>
+          <a:prstGeom prst="rect">
+            <a:avLst/>
+          </a:prstGeom>
+          <a:noFill/>
+          <a:ln/>
+        </p:spPr>
+        <p:txBody>
+          <a:bodyPr wrap="square" lIns="0" tIns="0" rIns="0" bIns="0" rtlCol="0" anchor="t"/>
+          <a:lstStyle/>
+          <a:p>
+            <a:pPr indent="0" marL="0">
+              <a:buNone/>
+            </a:pPr>
+            <a:r>
+              <a:rPr lang="en-US" sz="1050" dirty="0">
+                <a:solidFill>
+                  <a:srgbClr val="E6EAF2"/>
+                </a:solidFill>
+                <a:latin typeface="Calibri" pitchFamily="34" charset="0"/>
+                <a:ea typeface="Calibri" pitchFamily="34" charset="-122"/>
+                <a:cs typeface="Calibri" pitchFamily="34" charset="-120"/>
+              </a:rPr>
+              <a:t>Döngü başına alım 5 → 1, tutar −%86. 4 coin yatay bekledi, ETH yarım boyut. Hata 0; 48/48 döngü zincirde.</a:t>
+            </a:r>
+            <a:endParaRPr lang="en-US" sz="1050" dirty="0"/>
+          </a:p>
+        </p:txBody>
+      </p:sp>
+      <p:sp>
+        <p:nvSpPr>
+          <p:cNvPr id="32" name="Text 30"/>
+          <p:cNvSpPr/>
+          <p:nvPr/>
+        </p:nvSpPr>
+        <p:spPr>
+          <a:xfrm>
+            <a:off x="4846320" y="3730752"/>
+            <a:ext cx="3657600" cy="228600"/>
+          </a:xfrm>
+          <a:prstGeom prst="rect">
+            <a:avLst/>
+          </a:prstGeom>
+          <a:noFill/>
+          <a:ln/>
+        </p:spPr>
+        <p:txBody>
+          <a:bodyPr wrap="square" lIns="0" tIns="0" rIns="0" bIns="0" rtlCol="0" anchor="ctr"/>
+          <a:lstStyle/>
+          <a:p>
+            <a:pPr indent="0" marL="0">
+              <a:buNone/>
+            </a:pPr>
+            <a:r>
+              <a:rPr lang="en-US" sz="900" i="1" dirty="0">
+                <a:solidFill>
+                  <a:srgbClr val="8A94A8"/>
+                </a:solidFill>
+                <a:latin typeface="Calibri" pitchFamily="34" charset="0"/>
+                <a:ea typeface="Calibri" pitchFamily="34" charset="-122"/>
+                <a:cs typeface="Calibri" pitchFamily="34" charset="-120"/>
+              </a:rPr>
+              <a:t>Not: 34–44. döngülerde yapay zekâ kota yüzünden görüş vermedi.</a:t>
+            </a:r>
+            <a:endParaRPr lang="en-US" sz="900" dirty="0"/>
+          </a:p>
+        </p:txBody>
+      </p:sp>
+      <p:sp>
+        <p:nvSpPr>
+          <p:cNvPr id="33" name="Shape 31"/>
+          <p:cNvSpPr/>
+          <p:nvPr/>
+        </p:nvSpPr>
+        <p:spPr>
+          <a:xfrm>
+            <a:off x="457200" y="4114800"/>
+            <a:ext cx="8183880" cy="640080"/>
+          </a:xfrm>
+          <a:prstGeom prst="roundRect">
+            <a:avLst>
+              <a:gd name="adj" fmla="val 17143"/>
+            </a:avLst>
+          </a:prstGeom>
+          <a:solidFill>
+            <a:srgbClr val="1A2130"/>
+          </a:solidFill>
+          <a:ln w="9525">
+            <a:solidFill>
+              <a:srgbClr val="263043"/>
+            </a:solidFill>
+            <a:prstDash val="solid"/>
+          </a:ln>
+        </p:spPr>
+      </p:sp>
+      <p:sp>
+        <p:nvSpPr>
+          <p:cNvPr id="34" name="Text 32"/>
           <p:cNvSpPr/>
           <p:nvPr/>
         </p:nvSpPr>
@@ -8494,7 +8722,7 @@
                 <a:ea typeface="Cambria" pitchFamily="34" charset="-122"/>
                 <a:cs typeface="Cambria" pitchFamily="34" charset="-120"/>
               </a:rPr>
-              <a:t>40+</a:t>
+              <a:t>48</a:t>
             </a:r>
             <a:endParaRPr lang="en-US" sz="2800" dirty="0"/>
           </a:p>
@@ -8533,7 +8761,7 @@
                 <a:ea typeface="Calibri" pitchFamily="34" charset="-122"/>
                 <a:cs typeface="Calibri" pitchFamily="34" charset="-120"/>
               </a:rPr>
-              <a:t>döngü mühürlendi, hepsi açıldı</a:t>
+              <a:t>döngü mühürlendi ve eşleşti</a:t>
             </a:r>
             <a:endParaRPr lang="en-US" sz="1300" dirty="0"/>
           </a:p>

</xml_diff>

<commit_message>
docs: 3-minute final deck (5 slides) + motto 'Proof before profit', 3-min runbook, 2-min Q&A, TUTORIAL, T-017/Grinold/audit 80 numbers
Co-Authored-By: Claude Opus 5.5 <noreply@anthropic.com>
</commit_message>
<xml_diff>
--- a/docs/pitch/GRAIL-pitch.pptx
+++ b/docs/pitch/GRAIL-pitch.pptx
@@ -1584,7 +1584,7 @@
           <a:p>
             <a:r>
               <a:rPr lang="en-US" dirty="0"/>
-              <a:t>Risk tarafı tek cümle: aynı 30 günde en kötü düşüş %4,3, eşit ağırlıklı al-tut %14,5; acil durdurma hiç tetiklenmedi. Getiri daha düşük (+%2,0 ve +%8,8), bunu biz söylüyoruz. Kalite: karar Python'da, Avalanche kontratında ve tarayıcıda aynı şekilde kuruluyor ve hepsi aynı sonucu veriyor. Sonraki adımdan kısaca bahset. Sonra kapanış: 'Backtest yalan söyleyebilir. Avalanche söyleyemez.' ve sus.</a:t>
+              <a:t>Risk tarafı tek cümle: aynı 30 günde en kötü düşüş %4,5, eşit ağırlıklı al-tut %14,5; acil durdurma hiç tetiklenmedi. Getiri daha düşük (+%1,6 ve +%8,8), bunu biz söylüyoruz. Kalite: karar Python'da, Avalanche kontratında ve tarayıcıda aynı şekilde kuruluyor ve hepsi aynı sonucu veriyor. Sonraki adımdan kısaca bahset. Sonra kapanış: 'Backtest yalan söyleyebilir. Avalanche söyleyemez.' ve sus.</a:t>
             </a:r>
             <a:endParaRPr lang="en-US" dirty="0"/>
           </a:p>
@@ -1936,7 +1936,7 @@
           <a:p>
             <a:r>
               <a:rPr lang="en-US" dirty="0"/>
-              <a:t>Ajan piyasanın rejimine göre davranışını seçiyor. Trend varsa momentum alımı; piyasa yatay görünüyorsa alım yapmadan bekliyor. Rejimi Hurst değeriyle TAHMİN ediyoruz; 48 saatlik veride bu tahmin gürültülü, rastgele veride bile yaklaşık %41 'yatay' çıkıyor. O yüzden 'tespit' demiyoruz. İkinci kapı: kırılım olduysa geri dönüp seviyeyi test etmesini bekliyoruz; kırılım yoksa yarım, kırılım ve geri test varsa tam boyut. Bugün canlıda, deneme modunda, aynı piyasa verisiyle: döngü başına alım 5'ten 1'e, tutar −%86. 4 coin yatay göründüğü için bekledi, ETH kırılım olmadığı için yarım boyutla alındı. Motor hatası 0, 48/48 döngünün hepsi zincirde. Dürüst not: 34 ile 44. döngüler arasında yapay zekâ sağlayıcısı kota nedeniyle cevap vermedi; kararlar değişmeden geçti (fail-open). 30 günlük tekrar oynatmada işlem sayısı 382'den 220'ye, en kötü düşüş %7,5'ten %4,3'e indi.</a:t>
+              <a:t>Ajan piyasanın rejimine göre davranışını seçiyor. Trend varsa momentum alımı; piyasa yatay görünüyorsa ayrı bir ortalamaya dönüş (Ornstein-Uhlenbeck) koluna geçiyor. Rejimi Hurst değeriyle TAHMİN ediyoruz; 48 saatlik veride bu tahmin gürültülü, rastgele veride bile yaklaşık %41 'yatay' çıkıyor. O yüzden 'tespit' demiyoruz. İkinci kapı: kırılım olduysa geri dönüp seviyeyi test etmesini bekliyoruz; kırılım yoksa yarım, kırılım ve geri test varsa tam boyut. Bugün canlıda, deneme modunda, aynı piyasa verisiyle: döngü başına alım 5'ten 1'e, tutar −%86. 4 coin yatay göründüğü için bekledi, ETH kırılım olmadığı için yarım boyutla alındı. Motor hatası 0, 48/48 döngünün hepsi zincirde. Dürüst not: 34 ile 44. döngüler arasında yapay zekâ sağlayıcısı kota nedeniyle cevap vermedi; kararlar değişmeden geçti (fail-open). 30 günlük tekrar oynatmada işlem sayısı 382'den 295'ye, en kötü düşüş %7,5'ten %4,5'e indi.</a:t>
             </a:r>
             <a:endParaRPr lang="en-US" dirty="0"/>
           </a:p>
@@ -2024,7 +2024,7 @@
           <a:p>
             <a:r>
               <a:rPr lang="en-US" dirty="0"/>
-              <a:t>Puanın %35'i bu slaytta: otonomi. Döngü her 90 saniyede, kimse bir şeye tıklamadan çalışıyor. 4. ve 6. adımları göster: karar, emir daha ortada yokken Avalanche'a mühürleniyor; ajan piyasa cevap vermeden bağlanıyor. Beklemek de bir karar ve o da mühürleniyor. Zincirde 48 döngü var, hepsi açılmış ve npm run audit ile hepsi eşleşiyor. İnsanın işi kuralları (ayarları) koymak, işlemleri onaylamak değil.</a:t>
+              <a:t>Puanın %35'i bu slaytta: otonomi. Döngü her 90 saniyede, kimse bir şeye tıklamadan çalışıyor. 4. ve 6. adımları göster: karar, emir daha ortada yokken Avalanche'a mühürleniyor; ajan piyasa cevap vermeden bağlanıyor. Beklemek de bir karar ve o da mühürleniyor. Zincirde 80 döngü var, hepsi açılmış ve npm run audit ile hepsi eşleşiyor. İnsanın işi kuralları (ayarları) koymak, işlemleri onaylamak değil.</a:t>
             </a:r>
             <a:endParaRPr lang="en-US" dirty="0"/>
           </a:p>
@@ -2748,7 +2748,7 @@
         <p:spPr>
           <a:xfrm>
             <a:off x="457200" y="1828800"/>
-            <a:ext cx="4206240" cy="822960"/>
+            <a:ext cx="4389120" cy="868680"/>
           </a:xfrm>
           <a:prstGeom prst="rect">
             <a:avLst/>
@@ -2764,7 +2764,24 @@
               <a:buNone/>
             </a:pPr>
             <a:r>
-              <a:rPr lang="en-US" sz="2200" dirty="0">
+              <a:rPr lang="en-US" sz="2600" b="1" dirty="0">
+                <a:solidFill>
+                  <a:srgbClr val="E8B04B"/>
+                </a:solidFill>
+                <a:latin typeface="Cambria" pitchFamily="34" charset="0"/>
+                <a:ea typeface="Cambria" pitchFamily="34" charset="-122"/>
+                <a:cs typeface="Cambria" pitchFamily="34" charset="-120"/>
+              </a:rPr>
+              <a:t>Proof before profit.</a:t>
+            </a:r>
+            <a:endParaRPr lang="en-US" sz="2600" dirty="0"/>
+          </a:p>
+          <a:p>
+            <a:pPr indent="0" marL="0">
+              <a:buNone/>
+            </a:pPr>
+            <a:r>
+              <a:rPr lang="en-US" sz="1800" dirty="0">
                 <a:solidFill>
                   <a:srgbClr val="8A94A8"/>
                 </a:solidFill>
@@ -2772,9 +2789,9 @@
                 <a:ea typeface="Calibri" pitchFamily="34" charset="-122"/>
                 <a:cs typeface="Calibri" pitchFamily="34" charset="-120"/>
               </a:rPr>
-              <a:t>Sicili herkesçe doğrulanabilen otonom alım-satım ajanı.</a:t>
-            </a:r>
-            <a:endParaRPr lang="en-US" sz="2200" dirty="0"/>
+              <a:t>Önce kanıt, sonra kâr.</a:t>
+            </a:r>
+            <a:endParaRPr lang="en-US" sz="2600" dirty="0"/>
           </a:p>
         </p:txBody>
       </p:sp>
@@ -4477,7 +4494,7 @@
                 <a:ea typeface="Calibri" pitchFamily="34" charset="-122"/>
                 <a:cs typeface="Calibri" pitchFamily="34" charset="-120"/>
               </a:rPr>
-              <a:t>  →  48/48 MATCH (~1–2 dk)</a:t>
+              <a:t>  →  80/80 MATCH (~1–2 dk)</a:t>
             </a:r>
             <a:endParaRPr lang="en-US" sz="1200" dirty="0"/>
           </a:p>
@@ -4692,7 +4709,7 @@
                 <a:ea typeface="Cambria" pitchFamily="34" charset="-122"/>
                 <a:cs typeface="Cambria" pitchFamily="34" charset="-120"/>
               </a:rPr>
-              <a:t>%4,3</a:t>
+              <a:t>%4,5</a:t>
             </a:r>
             <a:endParaRPr lang="en-US" sz="2800" dirty="0"/>
           </a:p>
@@ -4797,7 +4814,7 @@
                 <a:ea typeface="Cambria" pitchFamily="34" charset="-122"/>
                 <a:cs typeface="Cambria" pitchFamily="34" charset="-120"/>
               </a:rPr>
-              <a:t>382 → 220</a:t>
+              <a:t>382 → 295</a:t>
             </a:r>
             <a:endParaRPr lang="en-US" sz="2800" dirty="0"/>
           </a:p>
@@ -4980,7 +4997,7 @@
                 <a:ea typeface="Calibri" pitchFamily="34" charset="-122"/>
                 <a:cs typeface="Calibri" pitchFamily="34" charset="-120"/>
               </a:rPr>
-              <a:t>30 günlük tekrar oynatma, gerçek OKX saatlik fiyatlarıyla, emir gönderilmeden. Getiri +%2,0, al-tut +%8,8: al-tuttan iyi olduğunu iddia etmiyoruz. Testler: engine 167 · agents 157 · kontrat 48.</a:t>
+              <a:t>30 günlük tekrar oynatma, gerçek OKX saatlik fiyatlarıyla, emir gönderilmeden. Getiri +%1,6, al-tut +%8,8: al-tuttan iyi olduğunu iddia etmiyoruz. Testler: engine 167 · agents 157 · kontrat 48.</a:t>
             </a:r>
             <a:endParaRPr lang="en-US" sz="1000" dirty="0"/>
           </a:p>
@@ -5042,6 +5059,45 @@
       <p:sp>
         <p:nvSpPr>
           <p:cNvPr id="15" name="Text 13"/>
+          <p:cNvSpPr/>
+          <p:nvPr/>
+        </p:nvSpPr>
+        <p:spPr>
+          <a:xfrm>
+            <a:off x="457200" y="4224528"/>
+            <a:ext cx="8229600" cy="274320"/>
+          </a:xfrm>
+          <a:prstGeom prst="rect">
+            <a:avLst/>
+          </a:prstGeom>
+          <a:noFill/>
+          <a:ln/>
+        </p:spPr>
+        <p:txBody>
+          <a:bodyPr wrap="square" lIns="0" tIns="0" rIns="0" bIns="0" rtlCol="0" anchor="ctr"/>
+          <a:lstStyle/>
+          <a:p>
+            <a:pPr indent="0" marL="0">
+              <a:buNone/>
+            </a:pPr>
+            <a:r>
+              <a:rPr lang="en-US" sz="1300" b="1" dirty="0">
+                <a:solidFill>
+                  <a:srgbClr val="E8B04B"/>
+                </a:solidFill>
+                <a:latin typeface="Calibri" pitchFamily="34" charset="0"/>
+                <a:ea typeface="Calibri" pitchFamily="34" charset="-122"/>
+                <a:cs typeface="Calibri" pitchFamily="34" charset="-120"/>
+              </a:rPr>
+              <a:t>GRAIL — Proof before profit. · Önce kanıt, sonra kâr.</a:t>
+            </a:r>
+            <a:endParaRPr lang="en-US" sz="1300" dirty="0"/>
+          </a:p>
+        </p:txBody>
+      </p:sp>
+      <p:sp>
+        <p:nvSpPr>
+          <p:cNvPr id="16" name="Text 14"/>
           <p:cNvSpPr/>
           <p:nvPr/>
         </p:nvSpPr>
@@ -7566,7 +7622,7 @@
                 <a:ea typeface="Calibri" pitchFamily="34" charset="-122"/>
                 <a:cs typeface="Calibri" pitchFamily="34" charset="-120"/>
               </a:rPr>
-              <a:t>bekler, alım yapmaz</a:t>
+              <a:t>ortalamaya dönüş (Ornstein-Uhlenbeck)</a:t>
             </a:r>
             <a:endParaRPr lang="en-US" sz="1300" dirty="0"/>
           </a:p>
@@ -7935,13 +7991,13 @@
             <a:r>
               <a:rPr lang="en-US" sz="1100" b="1" dirty="0">
                 <a:solidFill>
-                  <a:srgbClr val="8A94A8"/>
-                </a:solidFill>
-                <a:latin typeface="Calibri" pitchFamily="34" charset="0"/>
-                <a:ea typeface="Calibri" pitchFamily="34" charset="-122"/>
-                <a:cs typeface="Calibri" pitchFamily="34" charset="-120"/>
-              </a:rPr>
-              <a:t>0 · bekle</a:t>
+                  <a:srgbClr val="8B9CFF"/>
+                </a:solidFill>
+                <a:latin typeface="Calibri" pitchFamily="34" charset="0"/>
+                <a:ea typeface="Calibri" pitchFamily="34" charset="-122"/>
+                <a:cs typeface="Calibri" pitchFamily="34" charset="-120"/>
+              </a:rPr>
+              <a:t>ortalamaya dönüş</a:t>
             </a:r>
             <a:endParaRPr lang="en-US" sz="1100" dirty="0"/>
           </a:p>
@@ -8454,7 +8510,7 @@
                 <a:ea typeface="Calibri" pitchFamily="34" charset="-122"/>
                 <a:cs typeface="Calibri" pitchFamily="34" charset="-120"/>
               </a:rPr>
-              <a:t>Kapılar sadece azaltır, asla alım üretmez. </a:t>
+              <a:t>Momentum kapıları sadece azaltır, asla alım üretmez. </a:t>
             </a:r>
             <a:pPr indent="0" marL="0">
               <a:buNone/>
@@ -8468,7 +8524,7 @@
                 <a:ea typeface="Calibri" pitchFamily="34" charset="-122"/>
                 <a:cs typeface="Calibri" pitchFamily="34" charset="-120"/>
               </a:rPr>
-              <a:t>Satışlara dokunmaz. 30 günlük tekrar oynatmada işlem 382 → 220, en kötü düşüş %7,5 → %4,3.</a:t>
+              <a:t>Yatay piyasada ayrı bir ortalamaya dönüş kolu çalışır; limitler aynı. 30 günlük tekrar oynatma: işlem 382 → 295.</a:t>
             </a:r>
             <a:endParaRPr lang="en-US" sz="1300" dirty="0"/>
           </a:p>
@@ -8722,7 +8778,7 @@
                 <a:ea typeface="Cambria" pitchFamily="34" charset="-122"/>
                 <a:cs typeface="Cambria" pitchFamily="34" charset="-120"/>
               </a:rPr>
-              <a:t>48</a:t>
+              <a:t>80</a:t>
             </a:r>
             <a:endParaRPr lang="en-US" sz="2800" dirty="0"/>
           </a:p>

</xml_diff>